<commit_message>
Set 3 Dec 2027 as G-Cloud 15 readiness target
</commit_message>
<xml_diff>
--- a/g-cloud-briefing.pptx
+++ b/g-cloud-briefing.pptx
@@ -4183,7 +4183,7 @@
                 <a:ea typeface="Calibri" pitchFamily="34" charset="-122"/>
                 <a:cs typeface="Calibri" pitchFamily="34" charset="-120"/>
               </a:rPr>
-              <a:t>Build catalogue, rate card, policies, certifications &amp; case studies over the next 12–18 months — ready the moment the ~2028 window reopens. No need to rush.</a:t>
+              <a:t>Build catalogue, rate card, policies, certifications &amp; case studies — fully ready by our target date of 3 December 2027, well ahead of the window reopening (expected ~March 2028). No need to rush.</a:t>
             </a:r>
             <a:endParaRPr lang="en-US" sz="1250" dirty="0"/>
           </a:p>
@@ -5637,7 +5637,7 @@
                 <a:ea typeface="Calibri" pitchFamily="34" charset="-122"/>
                 <a:cs typeface="Calibri" pitchFamily="34" charset="-120"/>
               </a:rPr>
-              <a:t>G-Cloud 15 application (submit ~2028)</a:t>
+              <a:t>G-Cloud 15 ready by 3 Dec 2027</a:t>
             </a:r>
             <a:endParaRPr lang="en-US" sz="1200" dirty="0"/>
           </a:p>
@@ -8247,7 +8247,7 @@
                 <a:ea typeface="Cambria" pitchFamily="34" charset="-122"/>
                 <a:cs typeface="Cambria" pitchFamily="34" charset="-120"/>
               </a:rPr>
-              <a:t>Sep 2026</a:t>
+              <a:t>~Mar 2028</a:t>
             </a:r>
             <a:endParaRPr lang="en-US" sz="3000" dirty="0"/>
           </a:p>
@@ -8286,7 +8286,7 @@
                 <a:ea typeface="Calibri" pitchFamily="34" charset="-122"/>
                 <a:cs typeface="Calibri" pitchFamily="34" charset="-120"/>
               </a:rPr>
-              <a:t>G-Cloud 15 expected to go live (for suppliers who already applied)</a:t>
+              <a:t>Next window expected to open for new suppliers like us (Open Framework reopens ~18 months after Sep 2026 go-live)</a:t>
             </a:r>
             <a:endParaRPr lang="en-US" sz="1300" dirty="0"/>
           </a:p>
@@ -8347,7 +8347,7 @@
                 <a:ea typeface="Cambria" pitchFamily="34" charset="-122"/>
                 <a:cs typeface="Cambria" pitchFamily="34" charset="-120"/>
               </a:rPr>
-              <a:t>~2028</a:t>
+              <a:t>3 Dec 2027</a:t>
             </a:r>
             <a:endParaRPr lang="en-US" sz="3000" dirty="0"/>
           </a:p>
@@ -8386,7 +8386,7 @@
                 <a:ea typeface="Calibri" pitchFamily="34" charset="-122"/>
                 <a:cs typeface="Calibri" pitchFamily="34" charset="-120"/>
               </a:rPr>
-              <a:t>Next window for new suppliers like us (Open Framework reopens ~18 months after go-live)</a:t>
+              <a:t>Our internal target: fully ready, well ahead of the window opening</a:t>
             </a:r>
             <a:endParaRPr lang="en-US" sz="1300" dirty="0"/>
           </a:p>
@@ -8533,7 +8533,7 @@
                 <a:ea typeface="Calibri" pitchFamily="34" charset="-122"/>
                 <a:cs typeface="Calibri" pitchFamily="34" charset="-120"/>
               </a:rPr>
-              <a:t>No rush to submit something in weeks. We have ~18 months of genuine runway to prepare case studies, policies and certifications properly — and a nearer-term alternative, DOS7, went live in April 2026 and reopens every 18 months for bespoke-outcome work.</a:t>
+              <a:t>No rush to submit something in weeks. Targeting 3 December 2027 gives us a comfortable buffer to prepare case studies, policies and certifications properly, ready well before the window opens — and a nearer-term alternative, DOS7, went live in April 2026 and reopens every 18 months for bespoke-outcome work.</a:t>
             </a:r>
             <a:endParaRPr lang="en-US" sz="1250" dirty="0"/>
           </a:p>

</xml_diff>

<commit_message>
Add CE Plus, AWS/Terraform positioning, and iMpower/TrustMark references
</commit_message>
<xml_diff>
--- a/g-cloud-briefing.pptx
+++ b/g-cloud-briefing.pptx
@@ -2680,7 +2680,7 @@
                 <a:ea typeface="Calibri" pitchFamily="34" charset="-122"/>
                 <a:cs typeface="Calibri" pitchFamily="34" charset="-120"/>
               </a:rPr>
-              <a:t>Cyber Essentials — now mandatory</a:t>
+              <a:t>Cyber Essentials Plus — already held ✓</a:t>
             </a:r>
             <a:endParaRPr lang="en-US" sz="1150" dirty="0"/>
           </a:p>
@@ -2701,7 +2701,7 @@
                 <a:ea typeface="Calibri" pitchFamily="34" charset="-122"/>
                 <a:cs typeface="Calibri" pitchFamily="34" charset="-120"/>
               </a:rPr>
-              <a:t>ISO 27001 (strengthens bid)</a:t>
+              <a:t>ISO 27001 — status to confirm</a:t>
             </a:r>
             <a:endParaRPr lang="en-US" sz="1150" dirty="0"/>
           </a:p>
@@ -3468,7 +3468,7 @@
                 <a:ea typeface="Calibri" pitchFamily="34" charset="-122"/>
                 <a:cs typeface="Calibri" pitchFamily="34" charset="-120"/>
               </a:rPr>
-              <a:t>AI-powered document assessment</a:t>
+              <a:t>AI-powered document assessment (with TrustMark)</a:t>
             </a:r>
             <a:endParaRPr lang="en-US" sz="1250" dirty="0"/>
           </a:p>
@@ -3619,7 +3619,7 @@
                 <a:ea typeface="Calibri" pitchFamily="34" charset="-122"/>
                 <a:cs typeface="Calibri" pitchFamily="34" charset="-120"/>
               </a:rPr>
-              <a:t>Analytics / index platform</a:t>
+              <a:t>iMpower Index — analytics platform</a:t>
             </a:r>
             <a:endParaRPr lang="en-US" sz="1250" dirty="0"/>
           </a:p>
@@ -3848,7 +3848,7 @@
                 <a:ea typeface="Calibri" pitchFamily="34" charset="-122"/>
                 <a:cs typeface="Calibri" pitchFamily="34" charset="-120"/>
               </a:rPr>
-              <a:t>Pending internal validation before external use — plus reference architecture diagrams, Terraform structure examples, and a security/governance write-up as supporting technical artefacts.</a:t>
+              <a:t>Pending internal validation before external use. Given iMpower and TrustMark's government-adjacent profile, worth asking both for a named reference or quote — more compelling to buyers than an anonymised write-up alone.</a:t>
             </a:r>
             <a:endParaRPr lang="en-US" sz="1200" dirty="0"/>
           </a:p>
@@ -4917,7 +4917,7 @@
                 <a:ea typeface="Calibri" pitchFamily="34" charset="-122"/>
                 <a:cs typeface="Calibri" pitchFamily="34" charset="-120"/>
               </a:rPr>
-              <a:t>Certifications (Cyber Essentials, insurance)</a:t>
+              <a:t>Certifications (CE Plus renewal, ISO 27001, insurance)</a:t>
             </a:r>
             <a:endParaRPr lang="en-US" sz="1200" dirty="0"/>
           </a:p>
@@ -5157,7 +5157,7 @@
                 <a:ea typeface="Calibri" pitchFamily="34" charset="-122"/>
                 <a:cs typeface="Calibri" pitchFamily="34" charset="-120"/>
               </a:rPr>
-              <a:t>Case studies (4–5, validated internally)</a:t>
+              <a:t>Case studies &amp; references (incl. iMpower/TrustMark)</a:t>
             </a:r>
             <a:endParaRPr lang="en-US" sz="1200" dirty="0"/>
           </a:p>
@@ -9882,7 +9882,7 @@
                 <a:ea typeface="Calibri" pitchFamily="34" charset="-122"/>
                 <a:cs typeface="Calibri" pitchFamily="34" charset="-120"/>
               </a:rPr>
-              <a:t>AWS, Azure, networking, IAM</a:t>
+              <a:t>AWS-first; Azure via partners</a:t>
             </a:r>
             <a:endParaRPr lang="en-US" sz="1050" dirty="0"/>
           </a:p>
@@ -10170,7 +10170,7 @@
                 <a:ea typeface="Calibri" pitchFamily="34" charset="-122"/>
                 <a:cs typeface="Calibri" pitchFamily="34" charset="-120"/>
               </a:rPr>
-              <a:t>Terraform, Bicep, CloudFormation</a:t>
+              <a:t>Terraform-led; CloudFormation, Bicep</a:t>
             </a:r>
             <a:endParaRPr lang="en-US" sz="1050" dirty="0"/>
           </a:p>
@@ -10836,7 +10836,7 @@
                 <a:ea typeface="Calibri" pitchFamily="34" charset="-122"/>
                 <a:cs typeface="Calibri" pitchFamily="34" charset="-120"/>
               </a:rPr>
-              <a:t>Landing zones, governance, networking, identity</a:t>
+              <a:t>AWS-first landing zones &amp; governance; Azure via partners</a:t>
             </a:r>
             <a:endParaRPr lang="en-US" sz="1150" dirty="0"/>
           </a:p>
@@ -11216,7 +11216,7 @@
                 <a:ea typeface="Calibri" pitchFamily="34" charset="-122"/>
                 <a:cs typeface="Calibri" pitchFamily="34" charset="-120"/>
               </a:rPr>
-              <a:t>Terraform, Bicep, CloudFormation</a:t>
+              <a:t>Terraform-led; CloudFormation &amp; Bicep also delivered</a:t>
             </a:r>
             <a:endParaRPr lang="en-US" sz="1150" dirty="0"/>
           </a:p>
@@ -12069,13 +12069,13 @@
           <a:p>
             <a:pPr marL="342900" indent="-342900">
               <a:spcAft>
-                <a:spcPts val="1000"/>
+                <a:spcPts val="800"/>
               </a:spcAft>
               <a:buSzPct val="100000"/>
               <a:buChar char="•"/>
             </a:pPr>
             <a:r>
-              <a:rPr lang="en-US" sz="1250" dirty="0">
+              <a:rPr lang="en-US" sz="1200" dirty="0">
                 <a:solidFill>
                   <a:srgbClr val="1F2937"/>
                 </a:solidFill>
@@ -12085,18 +12085,18 @@
               </a:rPr>
               <a:t>Genuine, varied delivery history: architecture, DevOps, data engineering, governance, AI</a:t>
             </a:r>
-            <a:endParaRPr lang="en-US" sz="1250" dirty="0"/>
+            <a:endParaRPr lang="en-US" sz="1200" dirty="0"/>
           </a:p>
           <a:p>
             <a:pPr marL="342900" indent="-342900">
               <a:spcAft>
-                <a:spcPts val="1000"/>
+                <a:spcPts val="800"/>
               </a:spcAft>
               <a:buSzPct val="100000"/>
               <a:buChar char="•"/>
             </a:pPr>
             <a:r>
-              <a:rPr lang="en-US" sz="1250" dirty="0">
+              <a:rPr lang="en-US" sz="1200" dirty="0">
                 <a:solidFill>
                   <a:srgbClr val="1F2937"/>
                 </a:solidFill>
@@ -12106,18 +12106,18 @@
               </a:rPr>
               <a:t>Naturally “repeatable service, bespoke delivery” — exactly what G-Cloud buyers expect</a:t>
             </a:r>
-            <a:endParaRPr lang="en-US" sz="1250" dirty="0"/>
+            <a:endParaRPr lang="en-US" sz="1200" dirty="0"/>
           </a:p>
           <a:p>
             <a:pPr marL="342900" indent="-342900">
               <a:spcAft>
-                <a:spcPts val="1000"/>
+                <a:spcPts val="800"/>
               </a:spcAft>
               <a:buSzPct val="100000"/>
               <a:buChar char="•"/>
             </a:pPr>
             <a:r>
-              <a:rPr lang="en-US" sz="1250" dirty="0">
+              <a:rPr lang="en-US" sz="1200" dirty="0">
                 <a:solidFill>
                   <a:srgbClr val="1F2937"/>
                 </a:solidFill>
@@ -12125,20 +12125,20 @@
                 <a:ea typeface="Calibri" pitchFamily="34" charset="-122"/>
                 <a:cs typeface="Calibri" pitchFamily="34" charset="-120"/>
               </a:rPr>
-              <a:t>Existing project experience that can become case studies</a:t>
-            </a:r>
-            <a:endParaRPr lang="en-US" sz="1250" dirty="0"/>
+              <a:t>Cyber Essentials Plus already held — exceeds the mandatory Lot 3 baseline</a:t>
+            </a:r>
+            <a:endParaRPr lang="en-US" sz="1200" dirty="0"/>
           </a:p>
           <a:p>
             <a:pPr marL="342900" indent="-342900">
               <a:spcAft>
-                <a:spcPts val="1000"/>
+                <a:spcPts val="800"/>
               </a:spcAft>
               <a:buSzPct val="100000"/>
               <a:buChar char="•"/>
             </a:pPr>
             <a:r>
-              <a:rPr lang="en-US" sz="1250" dirty="0">
+              <a:rPr lang="en-US" sz="1200" dirty="0">
                 <a:solidFill>
                   <a:srgbClr val="1F2937"/>
                 </a:solidFill>
@@ -12146,9 +12146,30 @@
                 <a:ea typeface="Calibri" pitchFamily="34" charset="-122"/>
                 <a:cs typeface="Calibri" pitchFamily="34" charset="-120"/>
               </a:rPr>
+              <a:t>Existing relationships with iMpower &amp; TrustMark — both government-adjacent, strong case study/reference potential</a:t>
+            </a:r>
+            <a:endParaRPr lang="en-US" sz="1200" dirty="0"/>
+          </a:p>
+          <a:p>
+            <a:pPr marL="342900" indent="-342900">
+              <a:spcAft>
+                <a:spcPts val="800"/>
+              </a:spcAft>
+              <a:buSzPct val="100000"/>
+              <a:buChar char="•"/>
+            </a:pPr>
+            <a:r>
+              <a:rPr lang="en-US" sz="1200" dirty="0">
+                <a:solidFill>
+                  <a:srgbClr val="1F2937"/>
+                </a:solidFill>
+                <a:latin typeface="Calibri" pitchFamily="34" charset="0"/>
+                <a:ea typeface="Calibri" pitchFamily="34" charset="-122"/>
+                <a:cs typeface="Calibri" pitchFamily="34" charset="-120"/>
+              </a:rPr>
               <a:t>Bespoke day-rate pricing is normal for this supplier type, not a weakness</a:t>
             </a:r>
-            <a:endParaRPr lang="en-US" sz="1250" dirty="0"/>
+            <a:endParaRPr lang="en-US" sz="1200" dirty="0"/>
           </a:p>
         </p:txBody>
       </p:sp>
@@ -12336,7 +12357,7 @@
                 <a:ea typeface="Calibri" pitchFamily="34" charset="-122"/>
                 <a:cs typeface="Calibri" pitchFamily="34" charset="-120"/>
               </a:rPr>
-              <a:t>Certification status (Cyber Essentials, ISO 27001) needs confirming</a:t>
+              <a:t>ISO 27001 status needs confirming</a:t>
             </a:r>
             <a:endParaRPr lang="en-US" sz="1250" dirty="0"/>
           </a:p>

</xml_diff>